<commit_message>
Align every demo slide with current Before and After workflows
Add separate clickable workflow links, exact input and prerequisite panels, and updated speaking notes for all five pairs. Remove generic artifact cues, align section numbers with demo numbers, and clarify the complete Demo 1 seed run ID and expected denied-save warning.

Co-authored-by: Copilot App <223556219+Copilot@users.noreply.github.com>
</commit_message>
<xml_diff>
--- a/dxc-actions-office-hour-2026-10-13.pptx
+++ b/dxc-actions-office-hour-2026-10-13.pptx
@@ -792,7 +792,7 @@
           <a:lstStyle/>
           <a:p>
             <a:r>
-              <a:t>Welcome to our October GitHub Actions Office Hour. Today we will walk through five selected updates using a simple before-and-after comparison for each one. The topics are cache permissions, workflow execution protections, expired artifact visibility, bounded reporting, and runner readiness. The repository now contains just this presentation and ten self-contained workflow files. Each pair is numbered so we can open Before, run it, and then open After to see the change. The Before examples show older configuration patterns or assumptions on today's GitHub service; they do not bring retired service behavior back. All speaking notes and setup instructions are embedded in this deck. We will use fifty minutes for the presentation and demos and preserve the final ten minutes for questions. No demo changes a production runner fleet.</a:t>
+              <a:t>Welcome to our October GitHub Actions Office Hour. Today we will walk through five selected updates using a simple before-and-after comparison for each one. The topics are cache permissions, workflow execution protections, expired artifact visibility, bounded reporting, and runner readiness. The repository contains this presentation at its root, a README, and ten self-contained workflow files. Each pair is numbered so we can open Before, run it, and then open After to see the change. The Before examples show older configuration patterns or assumptions on today's GitHub service; they do not bring retired service behavior back. All speaking notes and setup instructions are embedded in this deck. We will use fifty minutes for the presentation and demos and preserve the final ten minutes for questions. No demo changes a production runner fleet.</a:t>
             </a:r>
           </a:p>
         </p:txBody>
@@ -1842,7 +1842,7 @@
           <a:lstStyle/>
           <a:p>
             <a:r>
-              <a:t>The private repository is seandorsett/dxc-actions-office-hour. Its current tree contains only the deck and the ten workflow files under dot-github slash workflows. The build source and original template have been preserved outside the repository, and prior versions remain in Git history. To run a pair, open Actions, choose its numbered Before workflow, and then its After workflow. Every file contains its own instructions and prerequisites. Demos one, three, and four use the normal scoped Actions token where needed. Demo two requires a repository administrator to configure the named file-scoped policy in Settings. Demo five requires the approved read credential in demo-admin; restrict that environment to the default branch and use required reviewers where your plan permits them. Seed Demo 3 BEFORE at least a day early and record its actual expiry. Rehearse before delivery; these workflow files have not been represented as successful live runs merely because they parse locally. Keep the DXC Internal deck in this private repository.</a:t>
+              <a:t>The private repository is seandorsett/dxc-actions-office-hour. Open the current deck named dxc-actions-office-hour-2026-10-13.pptx at the repository root, not a previously downloaded outputs slash slides copy. The root README summarizes the five updates and run instructions; the ten workflow files live under dot-github slash workflows. The build source and original template are preserved outside the repository and in earlier Git history. Each demo slide now links to its exact Before and After YAML files. To run a pair, open Actions, choose the numbered Before workflow, and then its After workflow. Demos one, three, and four use the normal scoped Actions token where needed. Demo two requires an administrator to configure a file-scoped policy in Settings. Demo five needs the approved read credential in demo-admin; restrict the environment to main and use reviewers where your plan permits them. Copy complete run IDs for demos one and three. Seed Demo 3 Before at least a day early and wait for its actual expiry and cleanup. Rehearse before delivery: do not infer live verification from file validation. Keep the DXC Internal deck private.</a:t>
             </a:r>
           </a:p>
         </p:txBody>
@@ -2192,7 +2192,7 @@
           <a:lstStyle/>
           <a:p>
             <a:r>
-              <a:t>Open the Actions tab in seandorsett/dxc-actions-office-hour. Select Demo 1 BEFORE, click Run workflow, and use the default branch. Say: The old approach lets this trusted event use its default cache capability. Open the completed summary and copy the Before run ID. Next select Demo 1 AFTER and paste that number into before_run_id. Say: We have now made the cache access explicit and limited it to read. Open the restored-content step, the attempted-save step, and the final summary. The text should restore, while the new candidate key should not appear in inventory. If the marker is missing, check that Before succeeded and that you copied its run ID. If a key unexpectedly exists, inspect the actual service logs and do not call the result successful. Use a real rehearsal run if the queue is slow. Transition: Now we will control whether an entire workflow may run.</a:t>
+              <a:t>Open the clickable Before file link on this slide to inspect demo-1-before.yml, then open Actions in seandorsett/dxc-actions-office-hour. Select Demo 1 BEFORE, click Run workflow, and use main. Say: The old approach lets this trusted event use its default cache capability. Open the completed summary and copy the entire numeric Before run ID, not the run number or a shortened value. Next inspect demo-1-after.yml through the After link and run it on main with that full value in before_run_id. After now verifies that this is a completed, successful Demo 1 Before run in the same repository; a wrong ID produces an actionable error. A missing seed cache fails at restore rather than a later missing-file check. Say: We have made cache access explicit and limited it to read. Open the restored-content step, attempted-save step, and summary. The text restores, while the new candidate key remains absent. The cache-write-denied warning in the save step is expected: it demonstrates the read-only boundary, not a failed comparison. If a candidate key unexpectedly exists, inspect actual logs and do not call the result successful. Use a completed rehearsal if queues are slow. Transition: Now we will control whether an entire workflow may run.</a:t>
             </a:r>
           </a:p>
         </p:txBody>
@@ -18483,7 +18483,7 @@
                 </a:solidFill>
                 <a:latin typeface="Arial"/>
               </a:rPr>
-              <a:t>7 | Artifact visibility change | Effective</a:t>
+              <a:t>3 | Artifact visibility change | Effective</a:t>
             </a:r>
           </a:p>
         </p:txBody>
@@ -19022,7 +19022,7 @@
                 </a:solidFill>
                 <a:latin typeface="Arial"/>
               </a:rPr>
-              <a:t>7 | Two simple workflows separated by real elapsed time</a:t>
+              <a:t>3 | Two simple workflows separated by real elapsed time</a:t>
             </a:r>
           </a:p>
         </p:txBody>
@@ -19978,48 +19978,6 @@
       </p:sp>
       <p:sp>
         <p:nvSpPr>
-          <p:cNvPr id="4" name="TextBox 3"/>
-          <p:cNvSpPr txBox="1"/>
-          <p:nvPr/>
-        </p:nvSpPr>
-        <p:spPr>
-          <a:xfrm>
-            <a:off x="594360" y="2395728"/>
-            <a:ext cx="13441680" cy="237744"/>
-          </a:xfrm>
-          <a:prstGeom prst="rect">
-            <a:avLst/>
-          </a:prstGeom>
-          <a:noFill/>
-        </p:spPr>
-        <p:txBody>
-          <a:bodyPr wrap="square" lIns="18288" rIns="18288" tIns="18288" bIns="18288" anchor="t">
-            <a:normAutofit/>
-          </a:bodyPr>
-          <a:lstStyle/>
-          <a:p>
-            <a:pPr algn="l">
-              <a:lnSpc>
-                <a:spcPct val="110000"/>
-              </a:lnSpc>
-              <a:spcAft>
-                <a:spcPts val="0"/>
-              </a:spcAft>
-            </a:pPr>
-            <a:r>
-              <a:rPr sz="1300" b="0">
-                <a:solidFill>
-                  <a:srgbClr val="345282"/>
-                </a:solidFill>
-                <a:latin typeface="Consolas"/>
-              </a:rPr>
-              <a:t>demo-3-before.yml  /  demo-3-after.yml</a:t>
-            </a:r>
-          </a:p>
-        </p:txBody>
-      </p:sp>
-      <p:sp>
-        <p:nvSpPr>
           <p:cNvPr id="5" name="Rounded Rectangle 4"/>
           <p:cNvSpPr/>
           <p:nvPr/>
@@ -20134,7 +20092,7 @@
                 </a:solidFill>
                 <a:latin typeface="Arial"/>
               </a:rPr>
-              <a:t>Run Before at least a day early. Keep its successful run ID.</a:t>
+              <a:t>Run Before at least a day early. Keep its FULL successful run ID.</a:t>
             </a:r>
           </a:p>
         </p:txBody>
@@ -20255,7 +20213,7 @@
                 </a:solidFill>
                 <a:latin typeface="Arial"/>
               </a:rPr>
-              <a:t>Run After with that before_run_id once expires_at has passed.</a:t>
+              <a:t>Run After with before_run_id after expires_at AND service cleanup.</a:t>
             </a:r>
           </a:p>
         </p:txBody>
@@ -20426,132 +20384,6 @@
       </p:sp>
       <p:sp>
         <p:nvSpPr>
-          <p:cNvPr id="15" name="TextBox 14"/>
-          <p:cNvSpPr txBox="1"/>
-          <p:nvPr/>
-        </p:nvSpPr>
-        <p:spPr>
-          <a:xfrm>
-            <a:off x="10917936" y="2980944"/>
-            <a:ext cx="2916936" cy="530352"/>
-          </a:xfrm>
-          <a:prstGeom prst="rect">
-            <a:avLst/>
-          </a:prstGeom>
-          <a:noFill/>
-        </p:spPr>
-        <p:txBody>
-          <a:bodyPr wrap="square" lIns="18288" rIns="18288" tIns="18288" bIns="18288" anchor="t">
-            <a:normAutofit/>
-          </a:bodyPr>
-          <a:lstStyle/>
-          <a:p>
-            <a:pPr algn="l">
-              <a:spcAft>
-                <a:spcPts val="800"/>
-              </a:spcAft>
-            </a:pPr>
-            <a:r>
-              <a:rPr sz="2300" b="1">
-                <a:solidFill>
-                  <a:srgbClr val="FFFFFF"/>
-                </a:solidFill>
-                <a:latin typeface="Arial"/>
-              </a:rPr>
-              <a:t>Run from GitHub</a:t>
-            </a:r>
-          </a:p>
-        </p:txBody>
-      </p:sp>
-      <p:sp>
-        <p:nvSpPr>
-          <p:cNvPr id="16" name="TextBox 15"/>
-          <p:cNvSpPr txBox="1"/>
-          <p:nvPr/>
-        </p:nvSpPr>
-        <p:spPr>
-          <a:xfrm>
-            <a:off x="10917936" y="3730752"/>
-            <a:ext cx="2916936" cy="2569463"/>
-          </a:xfrm>
-          <a:prstGeom prst="rect">
-            <a:avLst/>
-          </a:prstGeom>
-          <a:noFill/>
-        </p:spPr>
-        <p:txBody>
-          <a:bodyPr wrap="square" lIns="18288" rIns="18288" tIns="18288" bIns="18288" anchor="t">
-            <a:normAutofit/>
-          </a:bodyPr>
-          <a:lstStyle/>
-          <a:p>
-            <a:pPr algn="l">
-              <a:spcAft>
-                <a:spcPts val="800"/>
-              </a:spcAft>
-            </a:pPr>
-            <a:r>
-              <a:rPr sz="2000" b="0">
-                <a:solidFill>
-                  <a:srgbClr val="FFFFFF"/>
-                </a:solidFill>
-                <a:latin typeface="Arial"/>
-              </a:rPr>
-              <a:t>Actions tab</a:t>
-            </a:r>
-          </a:p>
-          <a:p>
-            <a:pPr algn="l">
-              <a:spcAft>
-                <a:spcPts val="800"/>
-              </a:spcAft>
-            </a:pPr>
-            <a:r>
-              <a:rPr sz="2000" b="0">
-                <a:solidFill>
-                  <a:srgbClr val="FFFFFF"/>
-                </a:solidFill>
-                <a:latin typeface="Arial"/>
-              </a:rPr>
-              <a:t>Manual trigger</a:t>
-            </a:r>
-          </a:p>
-          <a:p>
-            <a:pPr algn="l">
-              <a:spcAft>
-                <a:spcPts val="800"/>
-              </a:spcAft>
-            </a:pPr>
-            <a:r>
-              <a:rPr sz="2000" b="0">
-                <a:solidFill>
-                  <a:srgbClr val="FFFFFF"/>
-                </a:solidFill>
-                <a:latin typeface="Arial"/>
-              </a:rPr>
-              <a:t>Job summaries</a:t>
-            </a:r>
-          </a:p>
-          <a:p>
-            <a:pPr algn="l">
-              <a:spcAft>
-                <a:spcPts val="800"/>
-              </a:spcAft>
-            </a:pPr>
-            <a:r>
-              <a:rPr sz="2000" b="0">
-                <a:solidFill>
-                  <a:srgbClr val="FFFFFF"/>
-                </a:solidFill>
-                <a:latin typeface="Arial"/>
-              </a:rPr>
-              <a:t>Evidence artifacts</a:t>
-            </a:r>
-          </a:p>
-        </p:txBody>
-      </p:sp>
-      <p:sp>
-        <p:nvSpPr>
           <p:cNvPr id="17" name="Rounded Rectangle 16"/>
           <p:cNvSpPr/>
           <p:nvPr/>
@@ -20643,6 +20475,218 @@
                 <a:latin typeface="Arial"/>
               </a:rPr>
               <a:t>30-34 min</a:t>
+            </a:r>
+          </a:p>
+        </p:txBody>
+      </p:sp>
+      <p:sp>
+        <p:nvSpPr>
+          <p:cNvPr id="19" name="TextBox 18"/>
+          <p:cNvSpPr txBox="1"/>
+          <p:nvPr/>
+        </p:nvSpPr>
+        <p:spPr>
+          <a:xfrm>
+            <a:off x="594360" y="2395728"/>
+            <a:ext cx="6583680" cy="237744"/>
+          </a:xfrm>
+          <a:prstGeom prst="rect">
+            <a:avLst/>
+          </a:prstGeom>
+          <a:noFill/>
+        </p:spPr>
+        <p:txBody>
+          <a:bodyPr wrap="square" lIns="18288" rIns="18288" tIns="18288" bIns="18288" anchor="t">
+            <a:normAutofit/>
+          </a:bodyPr>
+          <a:lstStyle/>
+          <a:p>
+            <a:pPr algn="l">
+              <a:lnSpc>
+                <a:spcPct val="110000"/>
+              </a:lnSpc>
+              <a:spcAft>
+                <a:spcPts val="0"/>
+              </a:spcAft>
+            </a:pPr>
+            <a:r>
+              <a:rPr sz="1300" b="0">
+                <a:solidFill>
+                  <a:srgbClr val="345282"/>
+                </a:solidFill>
+                <a:latin typeface="Consolas"/>
+                <a:hlinkClick r:id="rId3"/>
+              </a:rPr>
+              <a:t>Before: demo-3-before.yml</a:t>
+            </a:r>
+          </a:p>
+        </p:txBody>
+      </p:sp>
+      <p:sp>
+        <p:nvSpPr>
+          <p:cNvPr id="20" name="TextBox 19"/>
+          <p:cNvSpPr txBox="1"/>
+          <p:nvPr/>
+        </p:nvSpPr>
+        <p:spPr>
+          <a:xfrm>
+            <a:off x="7452360" y="2395728"/>
+            <a:ext cx="6583680" cy="237744"/>
+          </a:xfrm>
+          <a:prstGeom prst="rect">
+            <a:avLst/>
+          </a:prstGeom>
+          <a:noFill/>
+        </p:spPr>
+        <p:txBody>
+          <a:bodyPr wrap="square" lIns="18288" rIns="18288" tIns="18288" bIns="18288" anchor="t">
+            <a:normAutofit/>
+          </a:bodyPr>
+          <a:lstStyle/>
+          <a:p>
+            <a:pPr algn="l">
+              <a:lnSpc>
+                <a:spcPct val="110000"/>
+              </a:lnSpc>
+              <a:spcAft>
+                <a:spcPts val="0"/>
+              </a:spcAft>
+            </a:pPr>
+            <a:r>
+              <a:rPr sz="1300" b="0">
+                <a:solidFill>
+                  <a:srgbClr val="345282"/>
+                </a:solidFill>
+                <a:latin typeface="Consolas"/>
+                <a:hlinkClick r:id="rId4"/>
+              </a:rPr>
+              <a:t>After: demo-3-after.yml</a:t>
+            </a:r>
+          </a:p>
+        </p:txBody>
+      </p:sp>
+      <p:sp>
+        <p:nvSpPr>
+          <p:cNvPr id="21" name="TextBox 20"/>
+          <p:cNvSpPr txBox="1"/>
+          <p:nvPr/>
+        </p:nvSpPr>
+        <p:spPr>
+          <a:xfrm>
+            <a:off x="10917936" y="2980944"/>
+            <a:ext cx="2916936" cy="530352"/>
+          </a:xfrm>
+          <a:prstGeom prst="rect">
+            <a:avLst/>
+          </a:prstGeom>
+          <a:noFill/>
+        </p:spPr>
+        <p:txBody>
+          <a:bodyPr wrap="square" lIns="18288" rIns="18288" tIns="18288" bIns="18288" anchor="t">
+            <a:normAutofit/>
+          </a:bodyPr>
+          <a:lstStyle/>
+          <a:p>
+            <a:pPr algn="l">
+              <a:spcAft>
+                <a:spcPts val="800"/>
+              </a:spcAft>
+            </a:pPr>
+            <a:r>
+              <a:rPr sz="2300" b="1">
+                <a:solidFill>
+                  <a:srgbClr val="FFFFFF"/>
+                </a:solidFill>
+                <a:latin typeface="Arial"/>
+              </a:rPr>
+              <a:t>Inputs + timing</a:t>
+            </a:r>
+          </a:p>
+        </p:txBody>
+      </p:sp>
+      <p:sp>
+        <p:nvSpPr>
+          <p:cNvPr id="22" name="TextBox 21"/>
+          <p:cNvSpPr txBox="1"/>
+          <p:nvPr/>
+        </p:nvSpPr>
+        <p:spPr>
+          <a:xfrm>
+            <a:off x="10917936" y="3730752"/>
+            <a:ext cx="2916936" cy="2569464"/>
+          </a:xfrm>
+          <a:prstGeom prst="rect">
+            <a:avLst/>
+          </a:prstGeom>
+          <a:noFill/>
+        </p:spPr>
+        <p:txBody>
+          <a:bodyPr wrap="square" lIns="18288" rIns="18288" tIns="18288" bIns="18288" anchor="t">
+            <a:normAutofit/>
+          </a:bodyPr>
+          <a:lstStyle/>
+          <a:p>
+            <a:pPr algn="l">
+              <a:spcAft>
+                <a:spcPts val="800"/>
+              </a:spcAft>
+            </a:pPr>
+            <a:r>
+              <a:rPr sz="2000" b="0">
+                <a:solidFill>
+                  <a:srgbClr val="FFFFFF"/>
+                </a:solidFill>
+                <a:latin typeface="Arial"/>
+              </a:rPr>
+              <a:t>Before: seed early</a:t>
+            </a:r>
+          </a:p>
+          <a:p>
+            <a:pPr algn="l">
+              <a:spcAft>
+                <a:spcPts val="800"/>
+              </a:spcAft>
+            </a:pPr>
+            <a:r>
+              <a:rPr sz="2000" b="0">
+                <a:solidFill>
+                  <a:srgbClr val="FFFFFF"/>
+                </a:solidFill>
+                <a:latin typeface="Arial"/>
+              </a:rPr>
+              <a:t>After: before_run_id</a:t>
+            </a:r>
+          </a:p>
+          <a:p>
+            <a:pPr algn="l">
+              <a:spcAft>
+                <a:spcPts val="800"/>
+              </a:spcAft>
+            </a:pPr>
+            <a:r>
+              <a:rPr sz="2000" b="0">
+                <a:solidFill>
+                  <a:srgbClr val="FFFFFF"/>
+                </a:solidFill>
+                <a:latin typeface="Arial"/>
+              </a:rPr>
+              <a:t>Wait past expires_at</a:t>
+            </a:r>
+          </a:p>
+          <a:p>
+            <a:pPr algn="l">
+              <a:spcAft>
+                <a:spcPts val="800"/>
+              </a:spcAft>
+            </a:pPr>
+            <a:r>
+              <a:rPr sz="2000" b="0">
+                <a:solidFill>
+                  <a:srgbClr val="FFFFFF"/>
+                </a:solidFill>
+                <a:latin typeface="Arial"/>
+              </a:rPr>
+              <a:t>Receipt: 14 days</a:t>
             </a:r>
           </a:p>
         </p:txBody>
@@ -20699,7 +20743,7 @@
                 </a:solidFill>
                 <a:latin typeface="Arial"/>
               </a:rPr>
-              <a:t>8 | Count accuracy and retrieval completeness</a:t>
+              <a:t>4 | Count accuracy and retrieval completeness</a:t>
             </a:r>
           </a:p>
         </p:txBody>
@@ -21252,7 +21296,7 @@
                 </a:solidFill>
                 <a:latin typeface="Arial"/>
               </a:rPr>
-              <a:t>8 | One UTC day; real API results; explicit saturation guard</a:t>
+              <a:t>4 | One UTC day; real API results; explicit saturation guard</a:t>
             </a:r>
           </a:p>
         </p:txBody>
@@ -22208,48 +22252,6 @@
       </p:sp>
       <p:sp>
         <p:nvSpPr>
-          <p:cNvPr id="4" name="TextBox 3"/>
-          <p:cNvSpPr txBox="1"/>
-          <p:nvPr/>
-        </p:nvSpPr>
-        <p:spPr>
-          <a:xfrm>
-            <a:off x="594360" y="2395728"/>
-            <a:ext cx="13441680" cy="237744"/>
-          </a:xfrm>
-          <a:prstGeom prst="rect">
-            <a:avLst/>
-          </a:prstGeom>
-          <a:noFill/>
-        </p:spPr>
-        <p:txBody>
-          <a:bodyPr wrap="square" lIns="18288" rIns="18288" tIns="18288" bIns="18288" anchor="t">
-            <a:normAutofit/>
-          </a:bodyPr>
-          <a:lstStyle/>
-          <a:p>
-            <a:pPr algn="l">
-              <a:lnSpc>
-                <a:spcPct val="110000"/>
-              </a:lnSpc>
-              <a:spcAft>
-                <a:spcPts val="0"/>
-              </a:spcAft>
-            </a:pPr>
-            <a:r>
-              <a:rPr sz="1300" b="0">
-                <a:solidFill>
-                  <a:srgbClr val="345282"/>
-                </a:solidFill>
-                <a:latin typeface="Consolas"/>
-              </a:rPr>
-              <a:t>demo-4-before.yml  /  demo-4-after.yml</a:t>
-            </a:r>
-          </a:p>
-        </p:txBody>
-      </p:sp>
-      <p:sp>
-        <p:nvSpPr>
           <p:cNvPr id="5" name="Rounded Rectangle 4"/>
           <p:cNvSpPr/>
           <p:nvPr/>
@@ -22485,7 +22487,7 @@
                 </a:solidFill>
                 <a:latin typeface="Arial"/>
               </a:rPr>
-              <a:t>Choose the UTC day of rehearsal runs; follow all below-cap pages.</a:t>
+              <a:t>Set utc_date to the rehearsal UTC day; follow all below-cap pages.</a:t>
             </a:r>
           </a:p>
         </p:txBody>
@@ -22656,132 +22658,6 @@
       </p:sp>
       <p:sp>
         <p:nvSpPr>
-          <p:cNvPr id="15" name="TextBox 14"/>
-          <p:cNvSpPr txBox="1"/>
-          <p:nvPr/>
-        </p:nvSpPr>
-        <p:spPr>
-          <a:xfrm>
-            <a:off x="10917936" y="2980944"/>
-            <a:ext cx="2916936" cy="530352"/>
-          </a:xfrm>
-          <a:prstGeom prst="rect">
-            <a:avLst/>
-          </a:prstGeom>
-          <a:noFill/>
-        </p:spPr>
-        <p:txBody>
-          <a:bodyPr wrap="square" lIns="18288" rIns="18288" tIns="18288" bIns="18288" anchor="t">
-            <a:normAutofit/>
-          </a:bodyPr>
-          <a:lstStyle/>
-          <a:p>
-            <a:pPr algn="l">
-              <a:spcAft>
-                <a:spcPts val="800"/>
-              </a:spcAft>
-            </a:pPr>
-            <a:r>
-              <a:rPr sz="2300" b="1">
-                <a:solidFill>
-                  <a:srgbClr val="FFFFFF"/>
-                </a:solidFill>
-                <a:latin typeface="Arial"/>
-              </a:rPr>
-              <a:t>Run from GitHub</a:t>
-            </a:r>
-          </a:p>
-        </p:txBody>
-      </p:sp>
-      <p:sp>
-        <p:nvSpPr>
-          <p:cNvPr id="16" name="TextBox 15"/>
-          <p:cNvSpPr txBox="1"/>
-          <p:nvPr/>
-        </p:nvSpPr>
-        <p:spPr>
-          <a:xfrm>
-            <a:off x="10917936" y="3730752"/>
-            <a:ext cx="2916936" cy="2569463"/>
-          </a:xfrm>
-          <a:prstGeom prst="rect">
-            <a:avLst/>
-          </a:prstGeom>
-          <a:noFill/>
-        </p:spPr>
-        <p:txBody>
-          <a:bodyPr wrap="square" lIns="18288" rIns="18288" tIns="18288" bIns="18288" anchor="t">
-            <a:normAutofit/>
-          </a:bodyPr>
-          <a:lstStyle/>
-          <a:p>
-            <a:pPr algn="l">
-              <a:spcAft>
-                <a:spcPts val="800"/>
-              </a:spcAft>
-            </a:pPr>
-            <a:r>
-              <a:rPr sz="2000" b="0">
-                <a:solidFill>
-                  <a:srgbClr val="FFFFFF"/>
-                </a:solidFill>
-                <a:latin typeface="Arial"/>
-              </a:rPr>
-              <a:t>Actions tab</a:t>
-            </a:r>
-          </a:p>
-          <a:p>
-            <a:pPr algn="l">
-              <a:spcAft>
-                <a:spcPts val="800"/>
-              </a:spcAft>
-            </a:pPr>
-            <a:r>
-              <a:rPr sz="2000" b="0">
-                <a:solidFill>
-                  <a:srgbClr val="FFFFFF"/>
-                </a:solidFill>
-                <a:latin typeface="Arial"/>
-              </a:rPr>
-              <a:t>Manual trigger</a:t>
-            </a:r>
-          </a:p>
-          <a:p>
-            <a:pPr algn="l">
-              <a:spcAft>
-                <a:spcPts val="800"/>
-              </a:spcAft>
-            </a:pPr>
-            <a:r>
-              <a:rPr sz="2000" b="0">
-                <a:solidFill>
-                  <a:srgbClr val="FFFFFF"/>
-                </a:solidFill>
-                <a:latin typeface="Arial"/>
-              </a:rPr>
-              <a:t>Job summaries</a:t>
-            </a:r>
-          </a:p>
-          <a:p>
-            <a:pPr algn="l">
-              <a:spcAft>
-                <a:spcPts val="800"/>
-              </a:spcAft>
-            </a:pPr>
-            <a:r>
-              <a:rPr sz="2000" b="0">
-                <a:solidFill>
-                  <a:srgbClr val="FFFFFF"/>
-                </a:solidFill>
-                <a:latin typeface="Arial"/>
-              </a:rPr>
-              <a:t>Evidence artifacts</a:t>
-            </a:r>
-          </a:p>
-        </p:txBody>
-      </p:sp>
-      <p:sp>
-        <p:nvSpPr>
           <p:cNvPr id="17" name="Rounded Rectangle 16"/>
           <p:cNvSpPr/>
           <p:nvPr/>
@@ -22873,6 +22749,218 @@
                 <a:latin typeface="Arial"/>
               </a:rPr>
               <a:t>37-40 min</a:t>
+            </a:r>
+          </a:p>
+        </p:txBody>
+      </p:sp>
+      <p:sp>
+        <p:nvSpPr>
+          <p:cNvPr id="19" name="TextBox 18"/>
+          <p:cNvSpPr txBox="1"/>
+          <p:nvPr/>
+        </p:nvSpPr>
+        <p:spPr>
+          <a:xfrm>
+            <a:off x="594360" y="2395728"/>
+            <a:ext cx="6583680" cy="237744"/>
+          </a:xfrm>
+          <a:prstGeom prst="rect">
+            <a:avLst/>
+          </a:prstGeom>
+          <a:noFill/>
+        </p:spPr>
+        <p:txBody>
+          <a:bodyPr wrap="square" lIns="18288" rIns="18288" tIns="18288" bIns="18288" anchor="t">
+            <a:normAutofit/>
+          </a:bodyPr>
+          <a:lstStyle/>
+          <a:p>
+            <a:pPr algn="l">
+              <a:lnSpc>
+                <a:spcPct val="110000"/>
+              </a:lnSpc>
+              <a:spcAft>
+                <a:spcPts val="0"/>
+              </a:spcAft>
+            </a:pPr>
+            <a:r>
+              <a:rPr sz="1300" b="0">
+                <a:solidFill>
+                  <a:srgbClr val="345282"/>
+                </a:solidFill>
+                <a:latin typeface="Consolas"/>
+                <a:hlinkClick r:id="rId3"/>
+              </a:rPr>
+              <a:t>Before: demo-4-before.yml</a:t>
+            </a:r>
+          </a:p>
+        </p:txBody>
+      </p:sp>
+      <p:sp>
+        <p:nvSpPr>
+          <p:cNvPr id="20" name="TextBox 19"/>
+          <p:cNvSpPr txBox="1"/>
+          <p:nvPr/>
+        </p:nvSpPr>
+        <p:spPr>
+          <a:xfrm>
+            <a:off x="7452360" y="2395728"/>
+            <a:ext cx="6583680" cy="237744"/>
+          </a:xfrm>
+          <a:prstGeom prst="rect">
+            <a:avLst/>
+          </a:prstGeom>
+          <a:noFill/>
+        </p:spPr>
+        <p:txBody>
+          <a:bodyPr wrap="square" lIns="18288" rIns="18288" tIns="18288" bIns="18288" anchor="t">
+            <a:normAutofit/>
+          </a:bodyPr>
+          <a:lstStyle/>
+          <a:p>
+            <a:pPr algn="l">
+              <a:lnSpc>
+                <a:spcPct val="110000"/>
+              </a:lnSpc>
+              <a:spcAft>
+                <a:spcPts val="0"/>
+              </a:spcAft>
+            </a:pPr>
+            <a:r>
+              <a:rPr sz="1300" b="0">
+                <a:solidFill>
+                  <a:srgbClr val="345282"/>
+                </a:solidFill>
+                <a:latin typeface="Consolas"/>
+                <a:hlinkClick r:id="rId4"/>
+              </a:rPr>
+              <a:t>After: demo-4-after.yml</a:t>
+            </a:r>
+          </a:p>
+        </p:txBody>
+      </p:sp>
+      <p:sp>
+        <p:nvSpPr>
+          <p:cNvPr id="21" name="TextBox 20"/>
+          <p:cNvSpPr txBox="1"/>
+          <p:nvPr/>
+        </p:nvSpPr>
+        <p:spPr>
+          <a:xfrm>
+            <a:off x="10917936" y="2980944"/>
+            <a:ext cx="2916936" cy="530352"/>
+          </a:xfrm>
+          <a:prstGeom prst="rect">
+            <a:avLst/>
+          </a:prstGeom>
+          <a:noFill/>
+        </p:spPr>
+        <p:txBody>
+          <a:bodyPr wrap="square" lIns="18288" rIns="18288" tIns="18288" bIns="18288" anchor="t">
+            <a:normAutofit/>
+          </a:bodyPr>
+          <a:lstStyle/>
+          <a:p>
+            <a:pPr algn="l">
+              <a:spcAft>
+                <a:spcPts val="800"/>
+              </a:spcAft>
+            </a:pPr>
+            <a:r>
+              <a:rPr sz="2300" b="1">
+                <a:solidFill>
+                  <a:srgbClr val="FFFFFF"/>
+                </a:solidFill>
+                <a:latin typeface="Arial"/>
+              </a:rPr>
+              <a:t>After input</a:t>
+            </a:r>
+          </a:p>
+        </p:txBody>
+      </p:sp>
+      <p:sp>
+        <p:nvSpPr>
+          <p:cNvPr id="22" name="TextBox 21"/>
+          <p:cNvSpPr txBox="1"/>
+          <p:nvPr/>
+        </p:nvSpPr>
+        <p:spPr>
+          <a:xfrm>
+            <a:off x="10917936" y="3730752"/>
+            <a:ext cx="2916936" cy="2569464"/>
+          </a:xfrm>
+          <a:prstGeom prst="rect">
+            <a:avLst/>
+          </a:prstGeom>
+          <a:noFill/>
+        </p:spPr>
+        <p:txBody>
+          <a:bodyPr wrap="square" lIns="18288" rIns="18288" tIns="18288" bIns="18288" anchor="t">
+            <a:normAutofit/>
+          </a:bodyPr>
+          <a:lstStyle/>
+          <a:p>
+            <a:pPr algn="l">
+              <a:spcAft>
+                <a:spcPts val="800"/>
+              </a:spcAft>
+            </a:pPr>
+            <a:r>
+              <a:rPr sz="2000" b="0">
+                <a:solidFill>
+                  <a:srgbClr val="FFFFFF"/>
+                </a:solidFill>
+                <a:latin typeface="Arial"/>
+              </a:rPr>
+              <a:t>utc_date</a:t>
+            </a:r>
+          </a:p>
+          <a:p>
+            <a:pPr algn="l">
+              <a:spcAft>
+                <a:spcPts val="800"/>
+              </a:spcAft>
+            </a:pPr>
+            <a:r>
+              <a:rPr sz="2000" b="0">
+                <a:solidFill>
+                  <a:srgbClr val="FFFFFF"/>
+                </a:solidFill>
+                <a:latin typeface="Arial"/>
+              </a:rPr>
+              <a:t>YYYY-MM-DD</a:t>
+            </a:r>
+          </a:p>
+          <a:p>
+            <a:pPr algn="l">
+              <a:spcAft>
+                <a:spcPts val="800"/>
+              </a:spcAft>
+            </a:pPr>
+            <a:r>
+              <a:rPr sz="2000" b="0">
+                <a:solidFill>
+                  <a:srgbClr val="FFFFFF"/>
+                </a:solidFill>
+                <a:latin typeface="Arial"/>
+              </a:rPr>
+              <a:t>Use rehearsal day.</a:t>
+            </a:r>
+          </a:p>
+          <a:p>
+            <a:pPr algn="l">
+              <a:spcAft>
+                <a:spcPts val="800"/>
+              </a:spcAft>
+            </a:pPr>
+            <a:r>
+              <a:rPr sz="2000" b="0">
+                <a:solidFill>
+                  <a:srgbClr val="FFFFFF"/>
+                </a:solidFill>
+                <a:latin typeface="Arial"/>
+              </a:rPr>
+              <a:t>UTC, not local time.</a:t>
             </a:r>
           </a:p>
         </p:txBody>
@@ -22929,7 +23017,7 @@
                 </a:solidFill>
                 <a:latin typeface="Arial"/>
               </a:rPr>
-              <a:t>9 | Enterprise Cloud enforcement begins 29 Sep 2026</a:t>
+              <a:t>5 | Enterprise Cloud enforcement begins 29 Sep 2026</a:t>
             </a:r>
           </a:p>
         </p:txBody>
@@ -23514,48 +23602,6 @@
       </p:sp>
       <p:sp>
         <p:nvSpPr>
-          <p:cNvPr id="4" name="TextBox 3"/>
-          <p:cNvSpPr txBox="1"/>
-          <p:nvPr/>
-        </p:nvSpPr>
-        <p:spPr>
-          <a:xfrm>
-            <a:off x="594360" y="2395728"/>
-            <a:ext cx="13441680" cy="237744"/>
-          </a:xfrm>
-          <a:prstGeom prst="rect">
-            <a:avLst/>
-          </a:prstGeom>
-          <a:noFill/>
-        </p:spPr>
-        <p:txBody>
-          <a:bodyPr wrap="square" lIns="18288" rIns="18288" tIns="18288" bIns="18288" anchor="t">
-            <a:normAutofit/>
-          </a:bodyPr>
-          <a:lstStyle/>
-          <a:p>
-            <a:pPr algn="l">
-              <a:lnSpc>
-                <a:spcPct val="110000"/>
-              </a:lnSpc>
-              <a:spcAft>
-                <a:spcPts val="0"/>
-              </a:spcAft>
-            </a:pPr>
-            <a:r>
-              <a:rPr sz="1300" b="0">
-                <a:solidFill>
-                  <a:srgbClr val="345282"/>
-                </a:solidFill>
-                <a:latin typeface="Consolas"/>
-              </a:rPr>
-              <a:t>demo-5-before.yml  /  demo-5-after.yml</a:t>
-            </a:r>
-          </a:p>
-        </p:txBody>
-      </p:sp>
-      <p:sp>
-        <p:nvSpPr>
           <p:cNvPr id="5" name="Rounded Rectangle 4"/>
           <p:cNvSpPr/>
           <p:nvPr/>
@@ -23670,7 +23716,7 @@
                 </a:solidFill>
                 <a:latin typeface="Arial"/>
               </a:rPr>
-              <a:t>Compare 2.329.0 with the registration floor. Runtime remains unknown.</a:t>
+              <a:t>Use version=2.329.0 for the local registration-floor comparison.</a:t>
             </a:r>
           </a:p>
         </p:txBody>
@@ -23791,7 +23837,7 @@
                 </a:solidFill>
                 <a:latin typeface="Arial"/>
               </a:rPr>
-              <a:t>Query GitHub for registration_deprecates_at and runtime_deprecates_at.</a:t>
+              <a:t>Use the same version; read registration and runtime deprecation dates.</a:t>
             </a:r>
           </a:p>
         </p:txBody>
@@ -23962,132 +24008,6 @@
       </p:sp>
       <p:sp>
         <p:nvSpPr>
-          <p:cNvPr id="15" name="TextBox 14"/>
-          <p:cNvSpPr txBox="1"/>
-          <p:nvPr/>
-        </p:nvSpPr>
-        <p:spPr>
-          <a:xfrm>
-            <a:off x="10917936" y="2980944"/>
-            <a:ext cx="2916936" cy="530352"/>
-          </a:xfrm>
-          <a:prstGeom prst="rect">
-            <a:avLst/>
-          </a:prstGeom>
-          <a:noFill/>
-        </p:spPr>
-        <p:txBody>
-          <a:bodyPr wrap="square" lIns="18288" rIns="18288" tIns="18288" bIns="18288" anchor="t">
-            <a:normAutofit/>
-          </a:bodyPr>
-          <a:lstStyle/>
-          <a:p>
-            <a:pPr algn="l">
-              <a:spcAft>
-                <a:spcPts val="800"/>
-              </a:spcAft>
-            </a:pPr>
-            <a:r>
-              <a:rPr sz="2300" b="1">
-                <a:solidFill>
-                  <a:srgbClr val="FFFFFF"/>
-                </a:solidFill>
-                <a:latin typeface="Arial"/>
-              </a:rPr>
-              <a:t>Run from GitHub</a:t>
-            </a:r>
-          </a:p>
-        </p:txBody>
-      </p:sp>
-      <p:sp>
-        <p:nvSpPr>
-          <p:cNvPr id="16" name="TextBox 15"/>
-          <p:cNvSpPr txBox="1"/>
-          <p:nvPr/>
-        </p:nvSpPr>
-        <p:spPr>
-          <a:xfrm>
-            <a:off x="10917936" y="3730752"/>
-            <a:ext cx="2916936" cy="2569463"/>
-          </a:xfrm>
-          <a:prstGeom prst="rect">
-            <a:avLst/>
-          </a:prstGeom>
-          <a:noFill/>
-        </p:spPr>
-        <p:txBody>
-          <a:bodyPr wrap="square" lIns="18288" rIns="18288" tIns="18288" bIns="18288" anchor="t">
-            <a:normAutofit/>
-          </a:bodyPr>
-          <a:lstStyle/>
-          <a:p>
-            <a:pPr algn="l">
-              <a:spcAft>
-                <a:spcPts val="800"/>
-              </a:spcAft>
-            </a:pPr>
-            <a:r>
-              <a:rPr sz="2000" b="0">
-                <a:solidFill>
-                  <a:srgbClr val="FFFFFF"/>
-                </a:solidFill>
-                <a:latin typeface="Arial"/>
-              </a:rPr>
-              <a:t>Actions tab</a:t>
-            </a:r>
-          </a:p>
-          <a:p>
-            <a:pPr algn="l">
-              <a:spcAft>
-                <a:spcPts val="800"/>
-              </a:spcAft>
-            </a:pPr>
-            <a:r>
-              <a:rPr sz="2000" b="0">
-                <a:solidFill>
-                  <a:srgbClr val="FFFFFF"/>
-                </a:solidFill>
-                <a:latin typeface="Arial"/>
-              </a:rPr>
-              <a:t>Manual trigger</a:t>
-            </a:r>
-          </a:p>
-          <a:p>
-            <a:pPr algn="l">
-              <a:spcAft>
-                <a:spcPts val="800"/>
-              </a:spcAft>
-            </a:pPr>
-            <a:r>
-              <a:rPr sz="2000" b="0">
-                <a:solidFill>
-                  <a:srgbClr val="FFFFFF"/>
-                </a:solidFill>
-                <a:latin typeface="Arial"/>
-              </a:rPr>
-              <a:t>Job summaries</a:t>
-            </a:r>
-          </a:p>
-          <a:p>
-            <a:pPr algn="l">
-              <a:spcAft>
-                <a:spcPts val="800"/>
-              </a:spcAft>
-            </a:pPr>
-            <a:r>
-              <a:rPr sz="2000" b="0">
-                <a:solidFill>
-                  <a:srgbClr val="FFFFFF"/>
-                </a:solidFill>
-                <a:latin typeface="Arial"/>
-              </a:rPr>
-              <a:t>Evidence artifacts</a:t>
-            </a:r>
-          </a:p>
-        </p:txBody>
-      </p:sp>
-      <p:sp>
-        <p:nvSpPr>
           <p:cNvPr id="17" name="Rounded Rectangle 16"/>
           <p:cNvSpPr/>
           <p:nvPr/>
@@ -24179,6 +24099,218 @@
                 <a:latin typeface="Arial"/>
               </a:rPr>
               <a:t>42-45 min</a:t>
+            </a:r>
+          </a:p>
+        </p:txBody>
+      </p:sp>
+      <p:sp>
+        <p:nvSpPr>
+          <p:cNvPr id="19" name="TextBox 18"/>
+          <p:cNvSpPr txBox="1"/>
+          <p:nvPr/>
+        </p:nvSpPr>
+        <p:spPr>
+          <a:xfrm>
+            <a:off x="594360" y="2395728"/>
+            <a:ext cx="6583680" cy="237744"/>
+          </a:xfrm>
+          <a:prstGeom prst="rect">
+            <a:avLst/>
+          </a:prstGeom>
+          <a:noFill/>
+        </p:spPr>
+        <p:txBody>
+          <a:bodyPr wrap="square" lIns="18288" rIns="18288" tIns="18288" bIns="18288" anchor="t">
+            <a:normAutofit/>
+          </a:bodyPr>
+          <a:lstStyle/>
+          <a:p>
+            <a:pPr algn="l">
+              <a:lnSpc>
+                <a:spcPct val="110000"/>
+              </a:lnSpc>
+              <a:spcAft>
+                <a:spcPts val="0"/>
+              </a:spcAft>
+            </a:pPr>
+            <a:r>
+              <a:rPr sz="1300" b="0">
+                <a:solidFill>
+                  <a:srgbClr val="345282"/>
+                </a:solidFill>
+                <a:latin typeface="Consolas"/>
+                <a:hlinkClick r:id="rId3"/>
+              </a:rPr>
+              <a:t>Before: demo-5-before.yml</a:t>
+            </a:r>
+          </a:p>
+        </p:txBody>
+      </p:sp>
+      <p:sp>
+        <p:nvSpPr>
+          <p:cNvPr id="20" name="TextBox 19"/>
+          <p:cNvSpPr txBox="1"/>
+          <p:nvPr/>
+        </p:nvSpPr>
+        <p:spPr>
+          <a:xfrm>
+            <a:off x="7452360" y="2395728"/>
+            <a:ext cx="6583680" cy="237744"/>
+          </a:xfrm>
+          <a:prstGeom prst="rect">
+            <a:avLst/>
+          </a:prstGeom>
+          <a:noFill/>
+        </p:spPr>
+        <p:txBody>
+          <a:bodyPr wrap="square" lIns="18288" rIns="18288" tIns="18288" bIns="18288" anchor="t">
+            <a:normAutofit/>
+          </a:bodyPr>
+          <a:lstStyle/>
+          <a:p>
+            <a:pPr algn="l">
+              <a:lnSpc>
+                <a:spcPct val="110000"/>
+              </a:lnSpc>
+              <a:spcAft>
+                <a:spcPts val="0"/>
+              </a:spcAft>
+            </a:pPr>
+            <a:r>
+              <a:rPr sz="1300" b="0">
+                <a:solidFill>
+                  <a:srgbClr val="345282"/>
+                </a:solidFill>
+                <a:latin typeface="Consolas"/>
+                <a:hlinkClick r:id="rId4"/>
+              </a:rPr>
+              <a:t>After: demo-5-after.yml</a:t>
+            </a:r>
+          </a:p>
+        </p:txBody>
+      </p:sp>
+      <p:sp>
+        <p:nvSpPr>
+          <p:cNvPr id="21" name="TextBox 20"/>
+          <p:cNvSpPr txBox="1"/>
+          <p:nvPr/>
+        </p:nvSpPr>
+        <p:spPr>
+          <a:xfrm>
+            <a:off x="10917936" y="2980944"/>
+            <a:ext cx="2916936" cy="530352"/>
+          </a:xfrm>
+          <a:prstGeom prst="rect">
+            <a:avLst/>
+          </a:prstGeom>
+          <a:noFill/>
+        </p:spPr>
+        <p:txBody>
+          <a:bodyPr wrap="square" lIns="18288" rIns="18288" tIns="18288" bIns="18288" anchor="t">
+            <a:normAutofit/>
+          </a:bodyPr>
+          <a:lstStyle/>
+          <a:p>
+            <a:pPr algn="l">
+              <a:spcAft>
+                <a:spcPts val="800"/>
+              </a:spcAft>
+            </a:pPr>
+            <a:r>
+              <a:rPr sz="2300" b="1">
+                <a:solidFill>
+                  <a:srgbClr val="FFFFFF"/>
+                </a:solidFill>
+                <a:latin typeface="Arial"/>
+              </a:rPr>
+              <a:t>Setup + input</a:t>
+            </a:r>
+          </a:p>
+        </p:txBody>
+      </p:sp>
+      <p:sp>
+        <p:nvSpPr>
+          <p:cNvPr id="22" name="TextBox 21"/>
+          <p:cNvSpPr txBox="1"/>
+          <p:nvPr/>
+        </p:nvSpPr>
+        <p:spPr>
+          <a:xfrm>
+            <a:off x="10917936" y="3730752"/>
+            <a:ext cx="2916936" cy="2569464"/>
+          </a:xfrm>
+          <a:prstGeom prst="rect">
+            <a:avLst/>
+          </a:prstGeom>
+          <a:noFill/>
+        </p:spPr>
+        <p:txBody>
+          <a:bodyPr wrap="square" lIns="18288" rIns="18288" tIns="18288" bIns="18288" anchor="t">
+            <a:normAutofit/>
+          </a:bodyPr>
+          <a:lstStyle/>
+          <a:p>
+            <a:pPr algn="l">
+              <a:spcAft>
+                <a:spcPts val="800"/>
+              </a:spcAft>
+            </a:pPr>
+            <a:r>
+              <a:rPr sz="1800" b="0">
+                <a:solidFill>
+                  <a:srgbClr val="FFFFFF"/>
+                </a:solidFill>
+                <a:latin typeface="Arial"/>
+              </a:rPr>
+              <a:t>version</a:t>
+            </a:r>
+          </a:p>
+          <a:p>
+            <a:pPr algn="l">
+              <a:spcAft>
+                <a:spcPts val="800"/>
+              </a:spcAft>
+            </a:pPr>
+            <a:r>
+              <a:rPr sz="1800" b="0">
+                <a:solidFill>
+                  <a:srgbClr val="FFFFFF"/>
+                </a:solidFill>
+                <a:latin typeface="Arial"/>
+              </a:rPr>
+              <a:t>Same for both files.</a:t>
+            </a:r>
+          </a:p>
+          <a:p>
+            <a:pPr algn="l">
+              <a:spcAft>
+                <a:spcPts val="800"/>
+              </a:spcAft>
+            </a:pPr>
+            <a:r>
+              <a:rPr sz="1800" b="0">
+                <a:solidFill>
+                  <a:srgbClr val="FFFFFF"/>
+                </a:solidFill>
+                <a:latin typeface="Arial"/>
+              </a:rPr>
+              <a:t>demo-admin</a:t>
+            </a:r>
+          </a:p>
+          <a:p>
+            <a:pPr algn="l">
+              <a:spcAft>
+                <a:spcPts val="800"/>
+              </a:spcAft>
+            </a:pPr>
+            <a:r>
+              <a:rPr sz="1800" b="0">
+                <a:solidFill>
+                  <a:srgbClr val="FFFFFF"/>
+                </a:solidFill>
+                <a:latin typeface="Arial"/>
+              </a:rPr>
+              <a:t>RUNNER_READ_TOKEN</a:t>
             </a:r>
           </a:p>
         </p:txBody>
@@ -27559,7 +27691,7 @@
                 </a:solidFill>
                 <a:latin typeface="Arial"/>
               </a:rPr>
-              <a:t>Deck plus ten Before/After workflows.</a:t>
+              <a:t>Root deck, README, and ten workflows.</a:t>
             </a:r>
           </a:p>
           <a:p>
@@ -30621,48 +30753,6 @@
       </p:sp>
       <p:sp>
         <p:nvSpPr>
-          <p:cNvPr id="4" name="TextBox 3"/>
-          <p:cNvSpPr txBox="1"/>
-          <p:nvPr/>
-        </p:nvSpPr>
-        <p:spPr>
-          <a:xfrm>
-            <a:off x="594360" y="2395728"/>
-            <a:ext cx="13441680" cy="237744"/>
-          </a:xfrm>
-          <a:prstGeom prst="rect">
-            <a:avLst/>
-          </a:prstGeom>
-          <a:noFill/>
-        </p:spPr>
-        <p:txBody>
-          <a:bodyPr wrap="square" lIns="18288" rIns="18288" tIns="18288" bIns="18288" anchor="t">
-            <a:normAutofit/>
-          </a:bodyPr>
-          <a:lstStyle/>
-          <a:p>
-            <a:pPr algn="l">
-              <a:lnSpc>
-                <a:spcPct val="110000"/>
-              </a:lnSpc>
-              <a:spcAft>
-                <a:spcPts val="0"/>
-              </a:spcAft>
-            </a:pPr>
-            <a:r>
-              <a:rPr sz="1300" b="0">
-                <a:solidFill>
-                  <a:srgbClr val="345282"/>
-                </a:solidFill>
-                <a:latin typeface="Consolas"/>
-              </a:rPr>
-              <a:t>demo-1-before.yml  /  demo-1-after.yml</a:t>
-            </a:r>
-          </a:p>
-        </p:txBody>
-      </p:sp>
-      <p:sp>
-        <p:nvSpPr>
           <p:cNvPr id="5" name="Rounded Rectangle 4"/>
           <p:cNvSpPr/>
           <p:nvPr/>
@@ -30777,7 +30867,7 @@
                 </a:solidFill>
                 <a:latin typeface="Arial"/>
               </a:rPr>
-              <a:t>Run Demo 1 BEFORE. Copy its run ID from the summary.</a:t>
+              <a:t>Run Demo 1 BEFORE on main. Copy its FULL run ID from the summary.</a:t>
             </a:r>
           </a:p>
         </p:txBody>
@@ -30898,7 +30988,7 @@
                 </a:solidFill>
                 <a:latin typeface="Arial"/>
               </a:rPr>
-              <a:t>Run Demo 1 AFTER with that before_run_id.</a:t>
+              <a:t>Run Demo 1 AFTER on main with before_run_id; it validates the seed run.</a:t>
             </a:r>
           </a:p>
         </p:txBody>
@@ -31069,132 +31159,6 @@
       </p:sp>
       <p:sp>
         <p:nvSpPr>
-          <p:cNvPr id="15" name="TextBox 14"/>
-          <p:cNvSpPr txBox="1"/>
-          <p:nvPr/>
-        </p:nvSpPr>
-        <p:spPr>
-          <a:xfrm>
-            <a:off x="10917936" y="2980944"/>
-            <a:ext cx="2916936" cy="530352"/>
-          </a:xfrm>
-          <a:prstGeom prst="rect">
-            <a:avLst/>
-          </a:prstGeom>
-          <a:noFill/>
-        </p:spPr>
-        <p:txBody>
-          <a:bodyPr wrap="square" lIns="18288" rIns="18288" tIns="18288" bIns="18288" anchor="t">
-            <a:normAutofit/>
-          </a:bodyPr>
-          <a:lstStyle/>
-          <a:p>
-            <a:pPr algn="l">
-              <a:spcAft>
-                <a:spcPts val="800"/>
-              </a:spcAft>
-            </a:pPr>
-            <a:r>
-              <a:rPr sz="2300" b="1">
-                <a:solidFill>
-                  <a:srgbClr val="FFFFFF"/>
-                </a:solidFill>
-                <a:latin typeface="Arial"/>
-              </a:rPr>
-              <a:t>Run from GitHub</a:t>
-            </a:r>
-          </a:p>
-        </p:txBody>
-      </p:sp>
-      <p:sp>
-        <p:nvSpPr>
-          <p:cNvPr id="16" name="TextBox 15"/>
-          <p:cNvSpPr txBox="1"/>
-          <p:nvPr/>
-        </p:nvSpPr>
-        <p:spPr>
-          <a:xfrm>
-            <a:off x="10917936" y="3730752"/>
-            <a:ext cx="2916936" cy="2569463"/>
-          </a:xfrm>
-          <a:prstGeom prst="rect">
-            <a:avLst/>
-          </a:prstGeom>
-          <a:noFill/>
-        </p:spPr>
-        <p:txBody>
-          <a:bodyPr wrap="square" lIns="18288" rIns="18288" tIns="18288" bIns="18288" anchor="t">
-            <a:normAutofit/>
-          </a:bodyPr>
-          <a:lstStyle/>
-          <a:p>
-            <a:pPr algn="l">
-              <a:spcAft>
-                <a:spcPts val="800"/>
-              </a:spcAft>
-            </a:pPr>
-            <a:r>
-              <a:rPr sz="2000" b="0">
-                <a:solidFill>
-                  <a:srgbClr val="FFFFFF"/>
-                </a:solidFill>
-                <a:latin typeface="Arial"/>
-              </a:rPr>
-              <a:t>Actions tab</a:t>
-            </a:r>
-          </a:p>
-          <a:p>
-            <a:pPr algn="l">
-              <a:spcAft>
-                <a:spcPts val="800"/>
-              </a:spcAft>
-            </a:pPr>
-            <a:r>
-              <a:rPr sz="2000" b="0">
-                <a:solidFill>
-                  <a:srgbClr val="FFFFFF"/>
-                </a:solidFill>
-                <a:latin typeface="Arial"/>
-              </a:rPr>
-              <a:t>Manual trigger</a:t>
-            </a:r>
-          </a:p>
-          <a:p>
-            <a:pPr algn="l">
-              <a:spcAft>
-                <a:spcPts val="800"/>
-              </a:spcAft>
-            </a:pPr>
-            <a:r>
-              <a:rPr sz="2000" b="0">
-                <a:solidFill>
-                  <a:srgbClr val="FFFFFF"/>
-                </a:solidFill>
-                <a:latin typeface="Arial"/>
-              </a:rPr>
-              <a:t>Job summaries</a:t>
-            </a:r>
-          </a:p>
-          <a:p>
-            <a:pPr algn="l">
-              <a:spcAft>
-                <a:spcPts val="800"/>
-              </a:spcAft>
-            </a:pPr>
-            <a:r>
-              <a:rPr sz="2000" b="0">
-                <a:solidFill>
-                  <a:srgbClr val="FFFFFF"/>
-                </a:solidFill>
-                <a:latin typeface="Arial"/>
-              </a:rPr>
-              <a:t>Evidence artifacts</a:t>
-            </a:r>
-          </a:p>
-        </p:txBody>
-      </p:sp>
-      <p:sp>
-        <p:nvSpPr>
           <p:cNvPr id="17" name="Rounded Rectangle 16"/>
           <p:cNvSpPr/>
           <p:nvPr/>
@@ -31286,6 +31250,218 @@
                 <a:latin typeface="Arial"/>
               </a:rPr>
               <a:t>10-15 min</a:t>
+            </a:r>
+          </a:p>
+        </p:txBody>
+      </p:sp>
+      <p:sp>
+        <p:nvSpPr>
+          <p:cNvPr id="19" name="TextBox 18"/>
+          <p:cNvSpPr txBox="1"/>
+          <p:nvPr/>
+        </p:nvSpPr>
+        <p:spPr>
+          <a:xfrm>
+            <a:off x="594360" y="2395728"/>
+            <a:ext cx="6583680" cy="237744"/>
+          </a:xfrm>
+          <a:prstGeom prst="rect">
+            <a:avLst/>
+          </a:prstGeom>
+          <a:noFill/>
+        </p:spPr>
+        <p:txBody>
+          <a:bodyPr wrap="square" lIns="18288" rIns="18288" tIns="18288" bIns="18288" anchor="t">
+            <a:normAutofit/>
+          </a:bodyPr>
+          <a:lstStyle/>
+          <a:p>
+            <a:pPr algn="l">
+              <a:lnSpc>
+                <a:spcPct val="110000"/>
+              </a:lnSpc>
+              <a:spcAft>
+                <a:spcPts val="0"/>
+              </a:spcAft>
+            </a:pPr>
+            <a:r>
+              <a:rPr sz="1300" b="0">
+                <a:solidFill>
+                  <a:srgbClr val="345282"/>
+                </a:solidFill>
+                <a:latin typeface="Consolas"/>
+                <a:hlinkClick r:id="rId3"/>
+              </a:rPr>
+              <a:t>Before: demo-1-before.yml</a:t>
+            </a:r>
+          </a:p>
+        </p:txBody>
+      </p:sp>
+      <p:sp>
+        <p:nvSpPr>
+          <p:cNvPr id="20" name="TextBox 19"/>
+          <p:cNvSpPr txBox="1"/>
+          <p:nvPr/>
+        </p:nvSpPr>
+        <p:spPr>
+          <a:xfrm>
+            <a:off x="7452360" y="2395728"/>
+            <a:ext cx="6583680" cy="237744"/>
+          </a:xfrm>
+          <a:prstGeom prst="rect">
+            <a:avLst/>
+          </a:prstGeom>
+          <a:noFill/>
+        </p:spPr>
+        <p:txBody>
+          <a:bodyPr wrap="square" lIns="18288" rIns="18288" tIns="18288" bIns="18288" anchor="t">
+            <a:normAutofit/>
+          </a:bodyPr>
+          <a:lstStyle/>
+          <a:p>
+            <a:pPr algn="l">
+              <a:lnSpc>
+                <a:spcPct val="110000"/>
+              </a:lnSpc>
+              <a:spcAft>
+                <a:spcPts val="0"/>
+              </a:spcAft>
+            </a:pPr>
+            <a:r>
+              <a:rPr sz="1300" b="0">
+                <a:solidFill>
+                  <a:srgbClr val="345282"/>
+                </a:solidFill>
+                <a:latin typeface="Consolas"/>
+                <a:hlinkClick r:id="rId4"/>
+              </a:rPr>
+              <a:t>After: demo-1-after.yml</a:t>
+            </a:r>
+          </a:p>
+        </p:txBody>
+      </p:sp>
+      <p:sp>
+        <p:nvSpPr>
+          <p:cNvPr id="21" name="TextBox 20"/>
+          <p:cNvSpPr txBox="1"/>
+          <p:nvPr/>
+        </p:nvSpPr>
+        <p:spPr>
+          <a:xfrm>
+            <a:off x="10917936" y="2980944"/>
+            <a:ext cx="2916936" cy="530352"/>
+          </a:xfrm>
+          <a:prstGeom prst="rect">
+            <a:avLst/>
+          </a:prstGeom>
+          <a:noFill/>
+        </p:spPr>
+        <p:txBody>
+          <a:bodyPr wrap="square" lIns="18288" rIns="18288" tIns="18288" bIns="18288" anchor="t">
+            <a:normAutofit/>
+          </a:bodyPr>
+          <a:lstStyle/>
+          <a:p>
+            <a:pPr algn="l">
+              <a:spcAft>
+                <a:spcPts val="800"/>
+              </a:spcAft>
+            </a:pPr>
+            <a:r>
+              <a:rPr sz="2300" b="1">
+                <a:solidFill>
+                  <a:srgbClr val="FFFFFF"/>
+                </a:solidFill>
+                <a:latin typeface="Arial"/>
+              </a:rPr>
+              <a:t>Inputs</a:t>
+            </a:r>
+          </a:p>
+        </p:txBody>
+      </p:sp>
+      <p:sp>
+        <p:nvSpPr>
+          <p:cNvPr id="22" name="TextBox 21"/>
+          <p:cNvSpPr txBox="1"/>
+          <p:nvPr/>
+        </p:nvSpPr>
+        <p:spPr>
+          <a:xfrm>
+            <a:off x="10917936" y="3730752"/>
+            <a:ext cx="2916936" cy="2569464"/>
+          </a:xfrm>
+          <a:prstGeom prst="rect">
+            <a:avLst/>
+          </a:prstGeom>
+          <a:noFill/>
+        </p:spPr>
+        <p:txBody>
+          <a:bodyPr wrap="square" lIns="18288" rIns="18288" tIns="18288" bIns="18288" anchor="t">
+            <a:normAutofit/>
+          </a:bodyPr>
+          <a:lstStyle/>
+          <a:p>
+            <a:pPr algn="l">
+              <a:spcAft>
+                <a:spcPts val="800"/>
+              </a:spcAft>
+            </a:pPr>
+            <a:r>
+              <a:rPr sz="2000" b="0">
+                <a:solidFill>
+                  <a:srgbClr val="FFFFFF"/>
+                </a:solidFill>
+                <a:latin typeface="Arial"/>
+              </a:rPr>
+              <a:t>Before: no input</a:t>
+            </a:r>
+          </a:p>
+          <a:p>
+            <a:pPr algn="l">
+              <a:spcAft>
+                <a:spcPts val="800"/>
+              </a:spcAft>
+            </a:pPr>
+            <a:r>
+              <a:rPr sz="2000" b="0">
+                <a:solidFill>
+                  <a:srgbClr val="FFFFFF"/>
+                </a:solidFill>
+                <a:latin typeface="Arial"/>
+              </a:rPr>
+              <a:t>After: full run ID</a:t>
+            </a:r>
+          </a:p>
+          <a:p>
+            <a:pPr algn="l">
+              <a:spcAft>
+                <a:spcPts val="800"/>
+              </a:spcAft>
+            </a:pPr>
+            <a:r>
+              <a:rPr sz="2000" b="0">
+                <a:solidFill>
+                  <a:srgbClr val="FFFFFF"/>
+                </a:solidFill>
+                <a:latin typeface="Arial"/>
+              </a:rPr>
+              <a:t>Key: before_run_id</a:t>
+            </a:r>
+          </a:p>
+          <a:p>
+            <a:pPr algn="l">
+              <a:spcAft>
+                <a:spcPts val="800"/>
+              </a:spcAft>
+            </a:pPr>
+            <a:r>
+              <a:rPr sz="2000" b="0">
+                <a:solidFill>
+                  <a:srgbClr val="FFFFFF"/>
+                </a:solidFill>
+                <a:latin typeface="Arial"/>
+              </a:rPr>
+              <a:t>Use main.</a:t>
             </a:r>
           </a:p>
         </p:txBody>
@@ -32673,48 +32849,6 @@
       </p:sp>
       <p:sp>
         <p:nvSpPr>
-          <p:cNvPr id="4" name="TextBox 3"/>
-          <p:cNvSpPr txBox="1"/>
-          <p:nvPr/>
-        </p:nvSpPr>
-        <p:spPr>
-          <a:xfrm>
-            <a:off x="594360" y="2395728"/>
-            <a:ext cx="13441680" cy="237744"/>
-          </a:xfrm>
-          <a:prstGeom prst="rect">
-            <a:avLst/>
-          </a:prstGeom>
-          <a:noFill/>
-        </p:spPr>
-        <p:txBody>
-          <a:bodyPr wrap="square" lIns="18288" rIns="18288" tIns="18288" bIns="18288" anchor="t">
-            <a:normAutofit/>
-          </a:bodyPr>
-          <a:lstStyle/>
-          <a:p>
-            <a:pPr algn="l">
-              <a:lnSpc>
-                <a:spcPct val="110000"/>
-              </a:lnSpc>
-              <a:spcAft>
-                <a:spcPts val="0"/>
-              </a:spcAft>
-            </a:pPr>
-            <a:r>
-              <a:rPr sz="1300" b="0">
-                <a:solidFill>
-                  <a:srgbClr val="345282"/>
-                </a:solidFill>
-                <a:latin typeface="Consolas"/>
-              </a:rPr>
-              <a:t>demo-2-before.yml  /  demo-2-after.yml</a:t>
-            </a:r>
-          </a:p>
-        </p:txBody>
-      </p:sp>
-      <p:sp>
-        <p:nvSpPr>
           <p:cNvPr id="5" name="Rounded Rectangle 4"/>
           <p:cNvSpPr/>
           <p:nvPr/>
@@ -33121,132 +33255,6 @@
       </p:sp>
       <p:sp>
         <p:nvSpPr>
-          <p:cNvPr id="15" name="TextBox 14"/>
-          <p:cNvSpPr txBox="1"/>
-          <p:nvPr/>
-        </p:nvSpPr>
-        <p:spPr>
-          <a:xfrm>
-            <a:off x="10917936" y="2980944"/>
-            <a:ext cx="2916936" cy="530352"/>
-          </a:xfrm>
-          <a:prstGeom prst="rect">
-            <a:avLst/>
-          </a:prstGeom>
-          <a:noFill/>
-        </p:spPr>
-        <p:txBody>
-          <a:bodyPr wrap="square" lIns="18288" rIns="18288" tIns="18288" bIns="18288" anchor="t">
-            <a:normAutofit/>
-          </a:bodyPr>
-          <a:lstStyle/>
-          <a:p>
-            <a:pPr algn="l">
-              <a:spcAft>
-                <a:spcPts val="800"/>
-              </a:spcAft>
-            </a:pPr>
-            <a:r>
-              <a:rPr sz="2300" b="1">
-                <a:solidFill>
-                  <a:srgbClr val="FFFFFF"/>
-                </a:solidFill>
-                <a:latin typeface="Arial"/>
-              </a:rPr>
-              <a:t>Run from GitHub</a:t>
-            </a:r>
-          </a:p>
-        </p:txBody>
-      </p:sp>
-      <p:sp>
-        <p:nvSpPr>
-          <p:cNvPr id="16" name="TextBox 15"/>
-          <p:cNvSpPr txBox="1"/>
-          <p:nvPr/>
-        </p:nvSpPr>
-        <p:spPr>
-          <a:xfrm>
-            <a:off x="10917936" y="3730752"/>
-            <a:ext cx="2916936" cy="2569463"/>
-          </a:xfrm>
-          <a:prstGeom prst="rect">
-            <a:avLst/>
-          </a:prstGeom>
-          <a:noFill/>
-        </p:spPr>
-        <p:txBody>
-          <a:bodyPr wrap="square" lIns="18288" rIns="18288" tIns="18288" bIns="18288" anchor="t">
-            <a:normAutofit/>
-          </a:bodyPr>
-          <a:lstStyle/>
-          <a:p>
-            <a:pPr algn="l">
-              <a:spcAft>
-                <a:spcPts val="800"/>
-              </a:spcAft>
-            </a:pPr>
-            <a:r>
-              <a:rPr sz="2000" b="0">
-                <a:solidFill>
-                  <a:srgbClr val="FFFFFF"/>
-                </a:solidFill>
-                <a:latin typeface="Arial"/>
-              </a:rPr>
-              <a:t>Actions tab</a:t>
-            </a:r>
-          </a:p>
-          <a:p>
-            <a:pPr algn="l">
-              <a:spcAft>
-                <a:spcPts val="800"/>
-              </a:spcAft>
-            </a:pPr>
-            <a:r>
-              <a:rPr sz="2000" b="0">
-                <a:solidFill>
-                  <a:srgbClr val="FFFFFF"/>
-                </a:solidFill>
-                <a:latin typeface="Arial"/>
-              </a:rPr>
-              <a:t>Manual trigger</a:t>
-            </a:r>
-          </a:p>
-          <a:p>
-            <a:pPr algn="l">
-              <a:spcAft>
-                <a:spcPts val="800"/>
-              </a:spcAft>
-            </a:pPr>
-            <a:r>
-              <a:rPr sz="2000" b="0">
-                <a:solidFill>
-                  <a:srgbClr val="FFFFFF"/>
-                </a:solidFill>
-                <a:latin typeface="Arial"/>
-              </a:rPr>
-              <a:t>Job summaries</a:t>
-            </a:r>
-          </a:p>
-          <a:p>
-            <a:pPr algn="l">
-              <a:spcAft>
-                <a:spcPts val="800"/>
-              </a:spcAft>
-            </a:pPr>
-            <a:r>
-              <a:rPr sz="2000" b="0">
-                <a:solidFill>
-                  <a:srgbClr val="FFFFFF"/>
-                </a:solidFill>
-                <a:latin typeface="Arial"/>
-              </a:rPr>
-              <a:t>Evidence artifacts</a:t>
-            </a:r>
-          </a:p>
-        </p:txBody>
-      </p:sp>
-      <p:sp>
-        <p:nvSpPr>
           <p:cNvPr id="17" name="Rounded Rectangle 16"/>
           <p:cNvSpPr/>
           <p:nvPr/>
@@ -33338,6 +33346,218 @@
                 <a:latin typeface="Arial"/>
               </a:rPr>
               <a:t>20-26 min</a:t>
+            </a:r>
+          </a:p>
+        </p:txBody>
+      </p:sp>
+      <p:sp>
+        <p:nvSpPr>
+          <p:cNvPr id="19" name="TextBox 18"/>
+          <p:cNvSpPr txBox="1"/>
+          <p:nvPr/>
+        </p:nvSpPr>
+        <p:spPr>
+          <a:xfrm>
+            <a:off x="594360" y="2395728"/>
+            <a:ext cx="6583680" cy="237744"/>
+          </a:xfrm>
+          <a:prstGeom prst="rect">
+            <a:avLst/>
+          </a:prstGeom>
+          <a:noFill/>
+        </p:spPr>
+        <p:txBody>
+          <a:bodyPr wrap="square" lIns="18288" rIns="18288" tIns="18288" bIns="18288" anchor="t">
+            <a:normAutofit/>
+          </a:bodyPr>
+          <a:lstStyle/>
+          <a:p>
+            <a:pPr algn="l">
+              <a:lnSpc>
+                <a:spcPct val="110000"/>
+              </a:lnSpc>
+              <a:spcAft>
+                <a:spcPts val="0"/>
+              </a:spcAft>
+            </a:pPr>
+            <a:r>
+              <a:rPr sz="1300" b="0">
+                <a:solidFill>
+                  <a:srgbClr val="345282"/>
+                </a:solidFill>
+                <a:latin typeface="Consolas"/>
+                <a:hlinkClick r:id="rId3"/>
+              </a:rPr>
+              <a:t>Before: demo-2-before.yml</a:t>
+            </a:r>
+          </a:p>
+        </p:txBody>
+      </p:sp>
+      <p:sp>
+        <p:nvSpPr>
+          <p:cNvPr id="20" name="TextBox 19"/>
+          <p:cNvSpPr txBox="1"/>
+          <p:nvPr/>
+        </p:nvSpPr>
+        <p:spPr>
+          <a:xfrm>
+            <a:off x="7452360" y="2395728"/>
+            <a:ext cx="6583680" cy="237744"/>
+          </a:xfrm>
+          <a:prstGeom prst="rect">
+            <a:avLst/>
+          </a:prstGeom>
+          <a:noFill/>
+        </p:spPr>
+        <p:txBody>
+          <a:bodyPr wrap="square" lIns="18288" rIns="18288" tIns="18288" bIns="18288" anchor="t">
+            <a:normAutofit/>
+          </a:bodyPr>
+          <a:lstStyle/>
+          <a:p>
+            <a:pPr algn="l">
+              <a:lnSpc>
+                <a:spcPct val="110000"/>
+              </a:lnSpc>
+              <a:spcAft>
+                <a:spcPts val="0"/>
+              </a:spcAft>
+            </a:pPr>
+            <a:r>
+              <a:rPr sz="1300" b="0">
+                <a:solidFill>
+                  <a:srgbClr val="345282"/>
+                </a:solidFill>
+                <a:latin typeface="Consolas"/>
+                <a:hlinkClick r:id="rId4"/>
+              </a:rPr>
+              <a:t>After: demo-2-after.yml</a:t>
+            </a:r>
+          </a:p>
+        </p:txBody>
+      </p:sp>
+      <p:sp>
+        <p:nvSpPr>
+          <p:cNvPr id="21" name="TextBox 20"/>
+          <p:cNvSpPr txBox="1"/>
+          <p:nvPr/>
+        </p:nvSpPr>
+        <p:spPr>
+          <a:xfrm>
+            <a:off x="10917936" y="2980944"/>
+            <a:ext cx="2916936" cy="530352"/>
+          </a:xfrm>
+          <a:prstGeom prst="rect">
+            <a:avLst/>
+          </a:prstGeom>
+          <a:noFill/>
+        </p:spPr>
+        <p:txBody>
+          <a:bodyPr wrap="square" lIns="18288" rIns="18288" tIns="18288" bIns="18288" anchor="t">
+            <a:normAutofit/>
+          </a:bodyPr>
+          <a:lstStyle/>
+          <a:p>
+            <a:pPr algn="l">
+              <a:spcAft>
+                <a:spcPts val="800"/>
+              </a:spcAft>
+            </a:pPr>
+            <a:r>
+              <a:rPr sz="2300" b="1">
+                <a:solidFill>
+                  <a:srgbClr val="FFFFFF"/>
+                </a:solidFill>
+                <a:latin typeface="Arial"/>
+              </a:rPr>
+              <a:t>Policy setup</a:t>
+            </a:r>
+          </a:p>
+        </p:txBody>
+      </p:sp>
+      <p:sp>
+        <p:nvSpPr>
+          <p:cNvPr id="22" name="TextBox 21"/>
+          <p:cNvSpPr txBox="1"/>
+          <p:nvPr/>
+        </p:nvSpPr>
+        <p:spPr>
+          <a:xfrm>
+            <a:off x="10917936" y="3730752"/>
+            <a:ext cx="2916936" cy="2569464"/>
+          </a:xfrm>
+          <a:prstGeom prst="rect">
+            <a:avLst/>
+          </a:prstGeom>
+          <a:noFill/>
+        </p:spPr>
+        <p:txBody>
+          <a:bodyPr wrap="square" lIns="18288" rIns="18288" tIns="18288" bIns="18288" anchor="t">
+            <a:normAutofit/>
+          </a:bodyPr>
+          <a:lstStyle/>
+          <a:p>
+            <a:pPr algn="l">
+              <a:spcAft>
+                <a:spcPts val="800"/>
+              </a:spcAft>
+            </a:pPr>
+            <a:r>
+              <a:rPr sz="2000" b="0">
+                <a:solidFill>
+                  <a:srgbClr val="FFFFFF"/>
+                </a:solidFill>
+                <a:latin typeface="Arial"/>
+              </a:rPr>
+              <a:t>Active policy</a:t>
+            </a:r>
+          </a:p>
+          <a:p>
+            <a:pPr algn="l">
+              <a:spcAft>
+                <a:spcPts val="800"/>
+              </a:spcAft>
+            </a:pPr>
+            <a:r>
+              <a:rPr sz="2000" b="0">
+                <a:solidFill>
+                  <a:srgbClr val="FFFFFF"/>
+                </a:solidFill>
+                <a:latin typeface="Arial"/>
+              </a:rPr>
+              <a:t>Exact After path</a:t>
+            </a:r>
+          </a:p>
+          <a:p>
+            <a:pPr algn="l">
+              <a:spcAft>
+                <a:spcPts val="800"/>
+              </a:spcAft>
+            </a:pPr>
+            <a:r>
+              <a:rPr sz="2000" b="0">
+                <a:solidFill>
+                  <a:srgbClr val="FFFFFF"/>
+                </a:solidFill>
+                <a:latin typeface="Arial"/>
+              </a:rPr>
+              <a:t>Allow push only</a:t>
+            </a:r>
+          </a:p>
+          <a:p>
+            <a:pPr algn="l">
+              <a:spcAft>
+                <a:spcPts val="800"/>
+              </a:spcAft>
+            </a:pPr>
+            <a:r>
+              <a:rPr sz="2000" b="0">
+                <a:solidFill>
+                  <a:srgbClr val="FFFFFF"/>
+                </a:solidFill>
+                <a:latin typeface="Arial"/>
+              </a:rPr>
+              <a:t>Show pre-job block</a:t>
             </a:r>
           </a:p>
         </p:txBody>

</xml_diff>

<commit_message>
Clarify expired artifact wording on slide 10
Replace UI jargon about an expired pill with an Expired status badge in slide text and speaker notes. Preserve all other slides, notes, and timing.

Co-authored-by: Copilot App <223556219+Copilot@users.noreply.github.com>
</commit_message>
<xml_diff>
--- a/dxc-actions-office-hour-2026-10-13.pptx
+++ b/dxc-actions-office-hour-2026-10-13.pptx
@@ -862,7 +862,7 @@
           <a:lstStyle/>
           <a:p>
             <a:r>
-              <a:t>The September twenty-fourth release removes expired artifacts from the Actions run summary and REST API. Previously an expired pill could remain after the files had gone. We cannot switch today's service back to that older display behavior. Instead, our Before workflow creates a real artifact and records its identity while it exists. Our After workflow observes the same artifact after natural expiry and service cleanup. That is a genuine lifecycle demonstration of the new visibility behavior, not a simulated old interface. The feature changes display and API visibility, not the artifact retention setting or billing rules. Retained logs can still show the original upload while those logs remain available. Our separate fourteen-day receipt lets us compare the original artifact identity and expiry with its later absence.</a:t>
+              <a:t>The September twenty-fourth release removes expired artifacts from the Actions run summary and REST API. Previously, artifact entries could remain visible with an 'Expired' status badge even after their files had been deleted. We cannot switch today's service back to that older display behavior. Instead, our Before workflow creates a real artifact and records its identity while it exists. Our After workflow observes the same artifact after natural expiry and service cleanup. That is a genuine lifecycle demonstration of the new visibility behavior, not a simulated old interface. The feature changes display and API visibility, not the artifact retention setting or billing rules. Retained logs can still show the original upload while those logs remain available. Our separate fourteen-day receipt lets us compare the original artifact identity and expiry with its later absence.</a:t>
             </a:r>
           </a:p>
         </p:txBody>
@@ -18643,7 +18643,7 @@
                 </a:solidFill>
                 <a:latin typeface="Arial"/>
               </a:rPr>
-              <a:t>An expired pill could remain visible.</a:t>
+              <a:t>Artifact entries could remain visible.</a:t>
             </a:r>
           </a:p>
           <a:p>
@@ -18659,7 +18659,7 @@
                 </a:solidFill>
                 <a:latin typeface="Arial"/>
               </a:rPr>
-              <a:t>The underlying files were already gone.</a:t>
+              <a:t>An 'Expired' status badge marked them.</a:t>
             </a:r>
           </a:p>
           <a:p>
@@ -18675,7 +18675,7 @@
                 </a:solidFill>
                 <a:latin typeface="Arial"/>
               </a:rPr>
-              <a:t>Consumers could mistake visibility for retained data.</a:t>
+              <a:t>Their files had already been deleted.</a:t>
             </a:r>
           </a:p>
         </p:txBody>

</xml_diff>